<commit_message>
docs: Add deployment link to README.md and clean up absolute links
</commit_message>
<xml_diff>
--- a/documents/AI-Powered Credit Risk Intelligence Platform.pptx
+++ b/documents/AI-Powered Credit Risk Intelligence Platform.pptx
@@ -6725,22 +6725,19 @@
             <p:ph type="title"/>
           </p:nvPr>
         </p:nvSpPr>
-        <p:spPr/>
+        <p:spPr>
+          <a:xfrm>
+            <a:off x="677334" y="609600"/>
+            <a:ext cx="8596668" cy="1139687"/>
+          </a:xfrm>
+        </p:spPr>
         <p:txBody>
           <a:bodyPr/>
           <a:lstStyle/>
           <a:p>
             <a:r>
               <a:rPr lang="en-IN" dirty="0"/>
-              <a:t>Data </a:t>
-            </a:r>
-            <a:r>
-              <a:rPr lang="en-IN"/>
-              <a:t>Processing &amp; </a:t>
-            </a:r>
-            <a:r>
-              <a:rPr lang="en-IN" dirty="0"/>
-              <a:t>EDA Insights</a:t>
+              <a:t>Data Processing &amp; EDA Insights</a:t>
             </a:r>
           </a:p>
         </p:txBody>
@@ -6761,7 +6758,12 @@
             <p:ph idx="1"/>
           </p:nvPr>
         </p:nvSpPr>
-        <p:spPr/>
+        <p:spPr>
+          <a:xfrm>
+            <a:off x="836360" y="2061197"/>
+            <a:ext cx="8596668" cy="3880773"/>
+          </a:xfrm>
+        </p:spPr>
         <p:txBody>
           <a:bodyPr>
             <a:normAutofit fontScale="92500"/>

</xml_diff>